<commit_message>
Fix deck Future Work slide: Friedman/Wilcoxon and Rainbow ablation were already done, not future work
</commit_message>
<xml_diff>
--- a/research/INCIT2026_presentation.pptx
+++ b/research/INCIT2026_presentation.pptx
@@ -4058,7 +4058,7 @@
                 <a:ea typeface="Calibri" pitchFamily="34" charset="-122"/>
                 <a:cs typeface="Calibri" pitchFamily="34" charset="-120"/>
               </a:rPr>
-              <a:t>Statistical rigor: Friedman + Wilcoxon vs. baseline agents across seeds</a:t>
+              <a:t>Scale past n=5 seeds -- current Wilcoxon floor (p=0.0625) blocks pairwise significance even on a clean sweep</a:t>
             </a:r>
             <a:endParaRPr lang="en-US" sz="1250" dirty="0"/>
           </a:p>
@@ -4120,7 +4120,7 @@
                 <a:ea typeface="Calibri" pitchFamily="34" charset="-122"/>
                 <a:cs typeface="Calibri" pitchFamily="34" charset="-120"/>
               </a:rPr>
-              <a:t>Expand curriculum to auth-bypass and SSRF-style multi-step chains</a:t>
+              <a:t>Multi-seed, multi-run replication of the live Table I scan (currently single-seed, unlike the 5-seed ablation study)</a:t>
             </a:r>
             <a:endParaRPr lang="en-US" sz="1250" dirty="0"/>
           </a:p>
@@ -4182,7 +4182,7 @@
                 <a:ea typeface="Calibri" pitchFamily="34" charset="-122"/>
                 <a:cs typeface="Calibri" pitchFamily="34" charset="-120"/>
               </a:rPr>
-              <a:t>Component-wise ablation of the Rainbow additions (PER / Noisy / multi-step)</a:t>
+              <a:t>Expand curriculum to auth-bypass and SSRF-style multi-step chains</a:t>
             </a:r>
             <a:endParaRPr lang="en-US" sz="1250" dirty="0"/>
           </a:p>

</xml_diff>